<commit_message>
fix(presentation): clarify data and analysis wording
Slide 4: exclusions now name stale valuations separately. Slide 6: the
scatter shows a random sample of 2,500; the median line and correlation
use all 6,095 eligible attackers. Slide 9: inputs standardised, no sharp
elbow, four interpretable but overlapping profiles. Slide 10 and backup
E: playing-time causal direction is unclear. Speaker notes and claim
verification updated to match.
</commit_message>
<xml_diff>
--- a/presentation/DATA400_market_value_backup_slides.pptx
+++ b/presentation/DATA400_market_value_backup_slides.pptx
@@ -112,7 +112,7 @@
   <p:extLst>
     <p:ext uri="{521415D9-36F7-43E2-AB2F-B90AF26B5E84}">
       <p14:sectionLst xmlns:p14="http://schemas.microsoft.com/office/powerpoint/2010/main">
-        <p14:section name="Backup" id="{bea5c91e-e689-0a71-9fa8-8831bd8ad419}">
+        <p14:section name="Backup" id="{e5152b83-7806-1e9b-235a-f98a2eee4973}">
           <p14:sldIdLst>
             <p14:sldId id="256"/>
             <p14:sldId id="257"/>
@@ -920,7 +920,7 @@
           <a:p>
             <a:r>
               <a:rPr lang="en-US" dirty="0"/>
-              <a:t>Exact exclusion counts in the order the rules were applied: 9 missing position, 5 missing birth date, 490 no valuation, 416 stale valuation. 23,328 rows (72.8%) have at least 450 minutes.
+              <a:t>Exact exclusion counts in the order the rules were applied: 9 missing position, 5 missing birth date, 490 no valuation by July 31, 416 with a valuation more than 365 days old (stale, not missing). 23,328 rows (72.8%) have at least 450 minutes.
 Remember: 920 excluded</a:t>
             </a:r>
             <a:endParaRPr lang="en-US" dirty="0"/>
@@ -1277,7 +1277,7 @@
           <a:p>
             <a:r>
               <a:rPr lang="en-US" dirty="0"/>
-              <a:t>Spearman 0.51 between minutes and value. Explain the two-way direction: clubs play players they value, and playing raises value.
+              <a:t>Spearman 0.51 between minutes and value. The causal direction is unclear: clubs may play players they already value, playing may raise visibility, and ability or club level may affect both. None of this was tested.
 Remember: 0.51
 Caution: Do not say more minutes cause higher value.</a:t>
             </a:r>
@@ -10800,7 +10800,7 @@
                   <a:schemeClr val="tx1"/>
                 </a:solidFill>
               </a:rPr>
-              <a:t>Likely runs both ways: valued players get picked, and playing raises visibility. Club level may drive both.</a:t>
+              <a:t>Causal direction is unclear: clubs may play players they already value, playing may raise visibility, and ability or club level may affect both. None of this was tested.</a:t>
             </a:r>
             <a:endParaRPr lang="en-US" sz="1200" dirty="0"/>
           </a:p>

</xml_diff>